<commit_message>
docs(c3): finalize delivery and upstream fix PR text
</commit_message>
<xml_diff>
--- a/c3_work/stage5_pr_delivery/C3_结项汇报_初稿.pptx
+++ b/c3_work/stage5_pr_delivery/C3_结项汇报_初稿.pptx
@@ -4576,8 +4576,8 @@
         </p:nvSpPr>
         <p:spPr>
           <a:xfrm>
-            <a:off x="640080" y="4681728"/>
-            <a:ext cx="10972800" cy="292608"/>
+            <a:off x="640080" y="4590288"/>
+            <a:ext cx="6309360" cy="292608"/>
           </a:xfrm>
           <a:prstGeom prst="rect">
             <a:avLst/>
@@ -4612,8 +4612,8 @@
         </p:nvSpPr>
         <p:spPr>
           <a:xfrm>
-            <a:off x="640080" y="5074920"/>
-            <a:ext cx="10972800" cy="384048"/>
+            <a:off x="640080" y="4937760"/>
+            <a:ext cx="6400800" cy="420624"/>
           </a:xfrm>
           <a:prstGeom prst="rect">
             <a:avLst/>
@@ -4628,7 +4628,7 @@
           <a:p>
             <a:pPr algn="l"/>
             <a:r>
-              <a:rPr sz="1200" b="1" i="0">
+              <a:rPr sz="1150" b="1" i="0">
                 <a:solidFill>
                   <a:srgbClr val="149E8C"/>
                 </a:solidFill>
@@ -4638,24 +4638,24 @@
               <a:t>▸ </a:t>
             </a:r>
             <a:r>
-              <a:rPr sz="1200" b="1" i="0">
+              <a:rPr sz="1150" b="1" i="0">
                 <a:solidFill>
                   <a:srgbClr val="FFFFFF"/>
                 </a:solidFill>
                 <a:latin typeface="Microsoft YaHei"/>
                 <a:ea typeface="Microsoft YaHei"/>
               </a:rPr>
-              <a:t>① 手动 push  </a:t>
-            </a:r>
-            <a:r>
-              <a:rPr sz="1100" b="0" i="0">
+              <a:t>① 修复分支已备  </a:t>
+            </a:r>
+            <a:r>
+              <a:rPr sz="1050" b="0" i="0">
                 <a:solidFill>
                   <a:srgbClr val="AFC2D2"/>
                 </a:solidFill>
                 <a:latin typeface="Microsoft YaHei"/>
                 <a:ea typeface="Microsoft YaHei"/>
               </a:rPr>
-              <a:t>8 个本地 commit → fork lycyhrc/YOLO-Master:c3-vpeft-smoke(按 PR 四节)</a:t>
+              <a:t>fix/vpeft-capacity-guard(2 commit) → 待 push 并开 PR</a:t>
             </a:r>
           </a:p>
         </p:txBody>
@@ -4668,8 +4668,8 @@
         </p:nvSpPr>
         <p:spPr>
           <a:xfrm>
-            <a:off x="640080" y="5532120"/>
-            <a:ext cx="10972800" cy="384048"/>
+            <a:off x="640080" y="5376672"/>
+            <a:ext cx="6400800" cy="420624"/>
           </a:xfrm>
           <a:prstGeom prst="rect">
             <a:avLst/>
@@ -4684,7 +4684,7 @@
           <a:p>
             <a:pPr algn="l"/>
             <a:r>
-              <a:rPr sz="1200" b="1" i="0">
+              <a:rPr sz="1150" b="1" i="0">
                 <a:solidFill>
                   <a:srgbClr val="149E8C"/>
                 </a:solidFill>
@@ -4694,24 +4694,24 @@
               <a:t>▸ </a:t>
             </a:r>
             <a:r>
-              <a:rPr sz="1200" b="1" i="0">
+              <a:rPr sz="1150" b="1" i="0">
                 <a:solidFill>
                   <a:srgbClr val="FFFFFF"/>
                 </a:solidFill>
                 <a:latin typeface="Microsoft YaHei"/>
                 <a:ea typeface="Microsoft YaHei"/>
               </a:rPr>
-              <a:t>② P2 issue  </a:t>
-            </a:r>
-            <a:r>
-              <a:rPr sz="1100" b="0" i="0">
+              <a:t>② 证据包  </a:t>
+            </a:r>
+            <a:r>
+              <a:rPr sz="1050" b="0" i="0">
                 <a:solidFill>
                   <a:srgbClr val="AFC2D2"/>
                 </a:solidFill>
                 <a:latin typeface="Microsoft YaHei"/>
                 <a:ea typeface="Microsoft YaHei"/>
               </a:rPr>
-              <a:t>planner cap&lt;8 修复 PR(草稿已备) + case-embedding 调研</a:t>
+              <a:t>push 本地 commit → fork lycyhrc/YOLO-Master:c3-vpeft-smoke</a:t>
             </a:r>
           </a:p>
         </p:txBody>
@@ -4724,8 +4724,8 @@
         </p:nvSpPr>
         <p:spPr>
           <a:xfrm>
-            <a:off x="640080" y="5989320"/>
-            <a:ext cx="10972800" cy="384048"/>
+            <a:off x="640080" y="5815584"/>
+            <a:ext cx="6400800" cy="420624"/>
           </a:xfrm>
           <a:prstGeom prst="rect">
             <a:avLst/>
@@ -4740,7 +4740,7 @@
           <a:p>
             <a:pPr algn="l"/>
             <a:r>
-              <a:rPr sz="1200" b="1" i="0">
+              <a:rPr sz="1150" b="1" i="0">
                 <a:solidFill>
                   <a:srgbClr val="149E8C"/>
                 </a:solidFill>
@@ -4750,7 +4750,7 @@
               <a:t>▸ </a:t>
             </a:r>
             <a:r>
-              <a:rPr sz="1200" b="1" i="0">
+              <a:rPr sz="1150" b="1" i="0">
                 <a:solidFill>
                   <a:srgbClr val="FFFFFF"/>
                 </a:solidFill>
@@ -4760,21 +4760,233 @@
               <a:t>③ 可选扩展  </a:t>
             </a:r>
             <a:r>
-              <a:rPr sz="1100" b="0" i="0">
+              <a:rPr sz="1050" b="0" i="0">
                 <a:solidFill>
                   <a:srgbClr val="AFC2D2"/>
                 </a:solidFill>
                 <a:latin typeface="Microsoft YaHei"/>
                 <a:ea typeface="Microsoft YaHei"/>
               </a:rPr>
-              <a:t>k=5/10/50/100 档位曲线(数据已就绪), GPU 低峰 run_supplement 即可</a:t>
-            </a:r>
-          </a:p>
-        </p:txBody>
-      </p:sp>
-      <p:sp>
-        <p:nvSpPr>
-          <p:cNvPr id="26" name="TextBox 25"/>
+              <a:t>k=5/10/50/100 档位曲线(数据就绪), GPU 低峰补跑</a:t>
+            </a:r>
+          </a:p>
+        </p:txBody>
+      </p:sp>
+      <p:sp>
+        <p:nvSpPr>
+          <p:cNvPr id="26" name="Rounded Rectangle 25"/>
+          <p:cNvSpPr/>
+          <p:nvPr/>
+        </p:nvSpPr>
+        <p:spPr>
+          <a:xfrm>
+            <a:off x="7269480" y="4480560"/>
+            <a:ext cx="4279392" cy="1737360"/>
+          </a:xfrm>
+          <a:prstGeom prst="roundRect">
+            <a:avLst>
+              <a:gd name="adj" fmla="val 6000"/>
+            </a:avLst>
+          </a:prstGeom>
+          <a:solidFill>
+            <a:srgbClr val="1B2A39"/>
+          </a:solidFill>
+          <a:ln w="15875">
+            <a:solidFill>
+              <a:srgbClr val="D98A2B"/>
+            </a:solidFill>
+          </a:ln>
+          <a:effectLst/>
+        </p:spPr>
+        <p:style>
+          <a:lnRef idx="1">
+            <a:schemeClr val="accent1"/>
+          </a:lnRef>
+          <a:fillRef idx="3">
+            <a:schemeClr val="accent1"/>
+          </a:fillRef>
+          <a:effectRef idx="2">
+            <a:schemeClr val="accent1"/>
+          </a:effectRef>
+          <a:fontRef idx="minor">
+            <a:schemeClr val="lt1"/>
+          </a:fontRef>
+        </p:style>
+        <p:txBody>
+          <a:bodyPr rtlCol="0" anchor="ctr"/>
+          <a:lstStyle/>
+          <a:p>
+            <a:pPr algn="ctr"/>
+          </a:p>
+        </p:txBody>
+      </p:sp>
+      <p:sp>
+        <p:nvSpPr>
+          <p:cNvPr id="27" name="TextBox 26"/>
+          <p:cNvSpPr txBox="1"/>
+          <p:nvPr/>
+        </p:nvSpPr>
+        <p:spPr>
+          <a:xfrm>
+            <a:off x="7452360" y="4608576"/>
+            <a:ext cx="3931920" cy="274320"/>
+          </a:xfrm>
+          <a:prstGeom prst="rect">
+            <a:avLst/>
+          </a:prstGeom>
+          <a:noFill/>
+        </p:spPr>
+        <p:txBody>
+          <a:bodyPr wrap="square" lIns="0" rIns="0" tIns="0" bIns="0" anchor="t">
+            <a:spAutoFit/>
+          </a:bodyPr>
+          <a:lstStyle/>
+          <a:p>
+            <a:pPr algn="l"/>
+            <a:r>
+              <a:rPr sz="1100" b="1" i="0">
+                <a:solidFill>
+                  <a:srgbClr val="D98A2B"/>
+                </a:solidFill>
+                <a:latin typeface="Microsoft YaHei"/>
+                <a:ea typeface="Microsoft YaHei"/>
+              </a:rPr>
+              <a:t>交付链接（占位 · 上传后替换）</a:t>
+            </a:r>
+          </a:p>
+        </p:txBody>
+      </p:sp>
+      <p:sp>
+        <p:nvSpPr>
+          <p:cNvPr id="28" name="TextBox 27"/>
+          <p:cNvSpPr txBox="1"/>
+          <p:nvPr/>
+        </p:nvSpPr>
+        <p:spPr>
+          <a:xfrm>
+            <a:off x="7452360" y="4992624"/>
+            <a:ext cx="3931920" cy="274320"/>
+          </a:xfrm>
+          <a:prstGeom prst="rect">
+            <a:avLst/>
+          </a:prstGeom>
+          <a:noFill/>
+        </p:spPr>
+        <p:txBody>
+          <a:bodyPr wrap="square" lIns="0" rIns="0" tIns="0" bIns="0" anchor="t">
+            <a:spAutoFit/>
+          </a:bodyPr>
+          <a:lstStyle/>
+          <a:p>
+            <a:pPr algn="l"/>
+            <a:r>
+              <a:rPr sz="950" b="1" i="0">
+                <a:solidFill>
+                  <a:srgbClr val="FFFFFF"/>
+                </a:solidFill>
+                <a:latin typeface="Microsoft YaHei"/>
+                <a:ea typeface="Microsoft YaHei"/>
+              </a:rPr>
+              <a:t>① 修复 PR  </a:t>
+            </a:r>
+            <a:r>
+              <a:rPr sz="950" b="1" i="0">
+                <a:solidFill>
+                  <a:srgbClr val="149E8C"/>
+                </a:solidFill>
+                <a:latin typeface="Microsoft YaHei"/>
+                <a:ea typeface="Microsoft YaHei"/>
+              </a:rPr>
+              <a:t>&lt;&lt;PR_LINK_PLACEHOLDER&gt;&gt;</a:t>
+            </a:r>
+          </a:p>
+        </p:txBody>
+      </p:sp>
+      <p:sp>
+        <p:nvSpPr>
+          <p:cNvPr id="29" name="TextBox 28"/>
+          <p:cNvSpPr txBox="1"/>
+          <p:nvPr/>
+        </p:nvSpPr>
+        <p:spPr>
+          <a:xfrm>
+            <a:off x="7452360" y="5321808"/>
+            <a:ext cx="3931920" cy="274320"/>
+          </a:xfrm>
+          <a:prstGeom prst="rect">
+            <a:avLst/>
+          </a:prstGeom>
+          <a:noFill/>
+        </p:spPr>
+        <p:txBody>
+          <a:bodyPr wrap="square" lIns="0" rIns="0" tIns="0" bIns="0" anchor="t">
+            <a:spAutoFit/>
+          </a:bodyPr>
+          <a:lstStyle/>
+          <a:p>
+            <a:pPr algn="l"/>
+            <a:r>
+              <a:rPr sz="950" b="1" i="0">
+                <a:solidFill>
+                  <a:srgbClr val="FFFFFF"/>
+                </a:solidFill>
+                <a:latin typeface="Microsoft YaHei"/>
+                <a:ea typeface="Microsoft YaHei"/>
+              </a:rPr>
+              <a:t>② 证据附件  </a:t>
+            </a:r>
+            <a:r>
+              <a:rPr sz="950" b="1" i="0">
+                <a:solidFill>
+                  <a:srgbClr val="149E8C"/>
+                </a:solidFill>
+                <a:latin typeface="Microsoft YaHei"/>
+                <a:ea typeface="Microsoft YaHei"/>
+              </a:rPr>
+              <a:t>&lt;&lt;EVIDENCE_LINK_PLACEHOLDER&gt;&gt;</a:t>
+            </a:r>
+          </a:p>
+        </p:txBody>
+      </p:sp>
+      <p:sp>
+        <p:nvSpPr>
+          <p:cNvPr id="30" name="TextBox 29"/>
+          <p:cNvSpPr txBox="1"/>
+          <p:nvPr/>
+        </p:nvSpPr>
+        <p:spPr>
+          <a:xfrm>
+            <a:off x="7452360" y="5742432"/>
+            <a:ext cx="3931920" cy="365760"/>
+          </a:xfrm>
+          <a:prstGeom prst="rect">
+            <a:avLst/>
+          </a:prstGeom>
+          <a:noFill/>
+        </p:spPr>
+        <p:txBody>
+          <a:bodyPr wrap="square" lIns="0" rIns="0" tIns="0" bIns="0" anchor="t">
+            <a:spAutoFit/>
+          </a:bodyPr>
+          <a:lstStyle/>
+          <a:p>
+            <a:pPr algn="l"/>
+            <a:r>
+              <a:rPr sz="850" b="0" i="0">
+                <a:solidFill>
+                  <a:srgbClr val="8FA3B5"/>
+                </a:solidFill>
+                <a:latin typeface="Microsoft YaHei"/>
+                <a:ea typeface="Microsoft YaHei"/>
+              </a:rPr>
+              <a:t>把 &lt;&lt;...&gt;&gt; 换成实际链接即可（正文“末页①”指本占位）</a:t>
+            </a:r>
+          </a:p>
+        </p:txBody>
+      </p:sp>
+      <p:sp>
+        <p:nvSpPr>
+          <p:cNvPr id="31" name="TextBox 30"/>
           <p:cNvSpPr txBox="1"/>
           <p:nvPr/>
         </p:nvSpPr>
@@ -4803,7 +5015,7 @@
                 <a:latin typeface="Microsoft YaHei"/>
                 <a:ea typeface="Microsoft YaHei"/>
               </a:rPr>
-              <a:t>数字来源: stage3_matrix/runs(21 单元) · stage4_analysis(2026-09-07 定稿)</a:t>
+              <a:t>数字来源: stage3_matrix/runs(21 单元) · stage4_analysis(2026-09-07 定稿) · stage5 交付 2026-09-11</a:t>
             </a:r>
           </a:p>
         </p:txBody>
@@ -12323,7 +12535,7 @@
             <a:r>
               <a:rPr sz="1100" b="1" i="0">
                 <a:solidFill>
-                  <a:srgbClr val="D98A2B"/>
+                  <a:srgbClr val="2E8B63"/>
                 </a:solidFill>
                 <a:latin typeface="Microsoft YaHei"/>
                 <a:ea typeface="Microsoft YaHei"/>
@@ -12333,12 +12545,12 @@
             <a:r>
               <a:rPr sz="1200" b="1" i="0">
                 <a:solidFill>
-                  <a:srgbClr val="D98A2B"/>
-                </a:solidFill>
-                <a:latin typeface="Microsoft YaHei"/>
-                <a:ea typeface="Microsoft YaHei"/>
-              </a:rPr>
-              <a:t>已知缺陷 cap&lt;8  </a:t>
+                  <a:srgbClr val="2E8B63"/>
+                </a:solidFill>
+                <a:latin typeface="Microsoft YaHei"/>
+                <a:ea typeface="Microsoft YaHei"/>
+              </a:rPr>
+              <a:t>缺陷已修 cap&lt;8  </a:t>
             </a:r>
           </a:p>
           <a:p>
@@ -12351,7 +12563,7 @@
                 <a:latin typeface="Microsoft YaHei"/>
                 <a:ea typeface="Microsoft YaHei"/>
               </a:rPr>
-              <a:t>0.conv/routing_network.2/dfl.conv 容量 &lt; 最小候选 rank 4 → placement_plan.py:117 raise; 本次以 lora_exclude_modules 规避(子串匹配, 如实记录), 修复见 P2 issue 草稿</a:t>
+              <a:t>0.conv/routing_network.2/dfl.conv 容量 &lt; 最小候选 rank(4): 原先求解器放行 → plan 校验抛错 → V-PEFT 静默降级 legacy; 已提修复 PR(C_cap 硬约束 + capacity_excluded 审计), 本报告数据仍是 exclude 规避口径未重跑 → 链接见末页①</a:t>
             </a:r>
           </a:p>
         </p:txBody>
@@ -14315,7 +14527,7 @@
                           <a:latin typeface="Microsoft YaHei"/>
                           <a:ea typeface="Microsoft YaHei"/>
                         </a:rPr>
-                        <a:t>缺陷取证(P2)</a:t>
+                        <a:t>缺陷修复(PR)</a:t>
                       </a:r>
                     </a:p>
                   </a:txBody>
@@ -14339,7 +14551,7 @@
                           <a:latin typeface="Microsoft YaHei"/>
                           <a:ea typeface="Microsoft YaHei"/>
                         </a:rPr>
-                        <a:t>stage4_analysis/p2/planner_bug_issue.md</a:t>
+                        <a:t>分支 fix/vpeft-capacity-guard</a:t>
                       </a:r>
                     </a:p>
                   </a:txBody>
@@ -14363,7 +14575,7 @@
                           <a:latin typeface="Microsoft YaHei"/>
                           <a:ea typeface="Microsoft YaHei"/>
                         </a:rPr>
-                        <a:t>cap&lt;8 ValueError 源码行号 + 建议修复</a:t>
+                        <a:t>C_cap 容量硬约束 + capacity_excluded 审计 + 未适配层冻结(2 commit · 链接见末页①)</a:t>
                       </a:r>
                     </a:p>
                   </a:txBody>

</xml_diff>

<commit_message>
docs(c3): rewrite the PR-279 body in the upstream section style
</commit_message>
<xml_diff>
--- a/c3_work/stage5_pr_delivery/C3_结项汇报_初稿.pptx
+++ b/c3_work/stage5_pr_delivery/C3_结项汇报_初稿.pptx
@@ -4599,7 +4599,7 @@
                 <a:latin typeface="Microsoft YaHei"/>
                 <a:ea typeface="Microsoft YaHei"/>
               </a:rPr>
-              <a:t>待办 / 下一步</a:t>
+              <a:t>交付状态 / 下一步</a:t>
             </a:r>
           </a:p>
         </p:txBody>
@@ -4645,7 +4645,7 @@
                 <a:latin typeface="Microsoft YaHei"/>
                 <a:ea typeface="Microsoft YaHei"/>
               </a:rPr>
-              <a:t>① 修复分支已备  </a:t>
+              <a:t>① 修复分支已 push  </a:t>
             </a:r>
             <a:r>
               <a:rPr sz="1050" b="0" i="0">
@@ -4655,7 +4655,7 @@
                 <a:latin typeface="Microsoft YaHei"/>
                 <a:ea typeface="Microsoft YaHei"/>
               </a:rPr>
-              <a:t>fix/vpeft-capacity-guard(2 commit) → 待 push 并开 PR</a:t>
+              <a:t>fix/vpeft-capacity-guard(2 commit); PR #279 待重填标题/正文</a:t>
             </a:r>
           </a:p>
         </p:txBody>
@@ -4701,7 +4701,7 @@
                 <a:latin typeface="Microsoft YaHei"/>
                 <a:ea typeface="Microsoft YaHei"/>
               </a:rPr>
-              <a:t>② 证据包  </a:t>
+              <a:t>② 证据包已 push  </a:t>
             </a:r>
             <a:r>
               <a:rPr sz="1050" b="0" i="0">
@@ -4711,7 +4711,7 @@
                 <a:latin typeface="Microsoft YaHei"/>
                 <a:ea typeface="Microsoft YaHei"/>
               </a:rPr>
-              <a:t>push 本地 commit → fork lycyhrc/YOLO-Master:c3-vpeft-smoke</a:t>
+              <a:t>fork lycyhrc/YOLO-Master:c3-vpeft-smoke(本地 commit 全部同步)</a:t>
             </a:r>
           </a:p>
         </p:txBody>
@@ -4828,7 +4828,7 @@
         </p:nvSpPr>
         <p:spPr>
           <a:xfrm>
-            <a:off x="7452360" y="4608576"/>
+            <a:off x="7452360" y="4590288"/>
             <a:ext cx="3931920" cy="274320"/>
           </a:xfrm>
           <a:prstGeom prst="rect">
@@ -4851,7 +4851,7 @@
                 <a:latin typeface="Microsoft YaHei"/>
                 <a:ea typeface="Microsoft YaHei"/>
               </a:rPr>
-              <a:t>交付链接（占位 · 上传后替换）</a:t>
+              <a:t>交付链接（② 待填 · 上传后替换）</a:t>
             </a:r>
           </a:p>
         </p:txBody>
@@ -4864,8 +4864,8 @@
         </p:nvSpPr>
         <p:spPr>
           <a:xfrm>
-            <a:off x="7452360" y="4992624"/>
-            <a:ext cx="3931920" cy="274320"/>
+            <a:off x="7452360" y="4919472"/>
+            <a:ext cx="3931920" cy="292608"/>
           </a:xfrm>
           <a:prstGeom prst="rect">
             <a:avLst/>
@@ -4887,7 +4887,7 @@
                 <a:latin typeface="Microsoft YaHei"/>
                 <a:ea typeface="Microsoft YaHei"/>
               </a:rPr>
-              <a:t>① 修复 PR  </a:t>
+              <a:t>① 上游修复 PR #279  </a:t>
             </a:r>
             <a:r>
               <a:rPr sz="950" b="1" i="0">
@@ -4897,7 +4897,7 @@
                 <a:latin typeface="Microsoft YaHei"/>
                 <a:ea typeface="Microsoft YaHei"/>
               </a:rPr>
-              <a:t>&lt;&lt;PR_LINK_PLACEHOLDER&gt;&gt;</a:t>
+              <a:t>已发起</a:t>
             </a:r>
           </a:p>
         </p:txBody>
@@ -4910,8 +4910,8 @@
         </p:nvSpPr>
         <p:spPr>
           <a:xfrm>
-            <a:off x="7452360" y="5321808"/>
-            <a:ext cx="3931920" cy="274320"/>
+            <a:off x="7452360" y="5248656"/>
+            <a:ext cx="3931920" cy="365760"/>
           </a:xfrm>
           <a:prstGeom prst="rect">
             <a:avLst/>
@@ -4926,6 +4926,42 @@
           <a:p>
             <a:pPr algn="l"/>
             <a:r>
+              <a:rPr sz="850" b="1" i="0">
+                <a:solidFill>
+                  <a:srgbClr val="149E8C"/>
+                </a:solidFill>
+                <a:latin typeface="Microsoft YaHei"/>
+                <a:ea typeface="Microsoft YaHei"/>
+              </a:rPr>
+              <a:t>Tencent/YOLO-Master/pull/279</a:t>
+            </a:r>
+          </a:p>
+        </p:txBody>
+      </p:sp>
+      <p:sp>
+        <p:nvSpPr>
+          <p:cNvPr id="30" name="TextBox 29"/>
+          <p:cNvSpPr txBox="1"/>
+          <p:nvPr/>
+        </p:nvSpPr>
+        <p:spPr>
+          <a:xfrm>
+            <a:off x="7452360" y="5705856"/>
+            <a:ext cx="3931920" cy="292608"/>
+          </a:xfrm>
+          <a:prstGeom prst="rect">
+            <a:avLst/>
+          </a:prstGeom>
+          <a:noFill/>
+        </p:spPr>
+        <p:txBody>
+          <a:bodyPr wrap="square" lIns="0" rIns="0" tIns="0" bIns="0" anchor="t">
+            <a:spAutoFit/>
+          </a:bodyPr>
+          <a:lstStyle/>
+          <a:p>
+            <a:pPr algn="l"/>
+            <a:r>
               <a:rPr sz="950" b="1" i="0">
                 <a:solidFill>
                   <a:srgbClr val="FFFFFF"/>
@@ -4944,42 +4980,6 @@
                 <a:ea typeface="Microsoft YaHei"/>
               </a:rPr>
               <a:t>&lt;&lt;EVIDENCE_LINK_PLACEHOLDER&gt;&gt;</a:t>
-            </a:r>
-          </a:p>
-        </p:txBody>
-      </p:sp>
-      <p:sp>
-        <p:nvSpPr>
-          <p:cNvPr id="30" name="TextBox 29"/>
-          <p:cNvSpPr txBox="1"/>
-          <p:nvPr/>
-        </p:nvSpPr>
-        <p:spPr>
-          <a:xfrm>
-            <a:off x="7452360" y="5742432"/>
-            <a:ext cx="3931920" cy="365760"/>
-          </a:xfrm>
-          <a:prstGeom prst="rect">
-            <a:avLst/>
-          </a:prstGeom>
-          <a:noFill/>
-        </p:spPr>
-        <p:txBody>
-          <a:bodyPr wrap="square" lIns="0" rIns="0" tIns="0" bIns="0" anchor="t">
-            <a:spAutoFit/>
-          </a:bodyPr>
-          <a:lstStyle/>
-          <a:p>
-            <a:pPr algn="l"/>
-            <a:r>
-              <a:rPr sz="850" b="0" i="0">
-                <a:solidFill>
-                  <a:srgbClr val="8FA3B5"/>
-                </a:solidFill>
-                <a:latin typeface="Microsoft YaHei"/>
-                <a:ea typeface="Microsoft YaHei"/>
-              </a:rPr>
-              <a:t>把 &lt;&lt;...&gt;&gt; 换成实际链接即可（正文“末页①”指本占位）</a:t>
             </a:r>
           </a:p>
         </p:txBody>
@@ -12563,7 +12563,7 @@
                 <a:latin typeface="Microsoft YaHei"/>
                 <a:ea typeface="Microsoft YaHei"/>
               </a:rPr>
-              <a:t>0.conv/routing_network.2/dfl.conv 容量 &lt; 最小候选 rank(4): 原先求解器放行 → plan 校验抛错 → V-PEFT 静默降级 legacy; 已提修复 PR(C_cap 硬约束 + capacity_excluded 审计), 本报告数据仍是 exclude 规避口径未重跑 → 链接见末页①</a:t>
+              <a:t>0.conv/routing_network.2/dfl.conv 容量 &lt; 最小候选 rank(4): 原先求解器放行 → plan 校验抛错 → V-PEFT 静默降级 legacy; 修复分支已推 fork 并开上游 PR #279(C_cap 硬约束 + capacity_excluded 审计), 本报告数据仍是 exclude 规避口径未重跑 → 链接见末页①</a:t>
             </a:r>
           </a:p>
         </p:txBody>
@@ -14551,7 +14551,7 @@
                           <a:latin typeface="Microsoft YaHei"/>
                           <a:ea typeface="Microsoft YaHei"/>
                         </a:rPr>
-                        <a:t>分支 fix/vpeft-capacity-guard</a:t>
+                        <a:t>分支 fix/vpeft-capacity-guard + PR #279</a:t>
                       </a:r>
                     </a:p>
                   </a:txBody>

</xml_diff>